<commit_message>
Record finalist schedule and product direction decisions
</commit_message>
<xml_diff>
--- a/docs/submission/chatxpt-slide-deck-proposal.pptx
+++ b/docs/submission/chatxpt-slide-deck-proposal.pptx
@@ -2546,12 +2546,28 @@
               </a:defRPr>
             </a:pPr>
             <a:r>
-              <a:rPr sz="1125" b="0">
+              <a:rPr lang="en-US" sz="1125" b="0" dirty="0">
                 <a:solidFill>
                   <a:srgbClr val="FFFFFF"/>
                 </a:solidFill>
               </a:rPr>
-              <a:t>Yong Chen Jun, Kevin (Team Lead)</a:t>
+              <a:t>Kevin Yong </a:t>
+            </a:r>
+            <a:r>
+              <a:rPr lang="en-SG" sz="1125" b="0" dirty="0">
+                <a:solidFill>
+                  <a:srgbClr val="FFFFFF"/>
+                </a:solidFill>
+              </a:rPr>
+              <a:t>(</a:t>
+            </a:r>
+            <a:r>
+              <a:rPr sz="1125" b="0" dirty="0">
+                <a:solidFill>
+                  <a:srgbClr val="FFFFFF"/>
+                </a:solidFill>
+              </a:rPr>
+              <a:t>Team Lead)</a:t>
             </a:r>
           </a:p>
           <a:p>
@@ -2563,7 +2579,7 @@
               </a:defRPr>
             </a:pPr>
             <a:r>
-              <a:rPr sz="1125" b="0">
+              <a:rPr sz="1125" b="0" dirty="0">
                 <a:solidFill>
                   <a:srgbClr val="FFFFFF"/>
                 </a:solidFill>

</xml_diff>